<commit_message>
Objective gradients are suppresed if constraints are violated.
</commit_message>
<xml_diff>
--- a/Slides/RoadMapForExploration.pptx
+++ b/Slides/RoadMapForExploration.pptx
@@ -3488,7 +3488,7 @@
         </p:nvSpPr>
         <p:spPr>
           <a:xfrm>
-            <a:off x="891251" y="2121061"/>
+            <a:off x="243068" y="2287445"/>
             <a:ext cx="2222340" cy="1307939"/>
           </a:xfrm>
           <a:prstGeom prst="roundRect">
@@ -3532,7 +3532,7 @@
                   <a:srgbClr val="FF0000"/>
                 </a:solidFill>
               </a:rPr>
-              <a:t>6 Materials</a:t>
+              <a:t>4 Materials</a:t>
             </a:r>
           </a:p>
           <a:p>
@@ -3565,7 +3565,7 @@
         </p:nvSpPr>
         <p:spPr>
           <a:xfrm>
-            <a:off x="4406096" y="5108775"/>
+            <a:off x="6628436" y="5432864"/>
             <a:ext cx="2222340" cy="1307939"/>
           </a:xfrm>
           <a:prstGeom prst="roundRect">
@@ -3642,7 +3642,7 @@
         </p:nvSpPr>
         <p:spPr>
           <a:xfrm>
-            <a:off x="1888603" y="4004842"/>
+            <a:off x="3626736" y="5208609"/>
             <a:ext cx="2222340" cy="1307939"/>
           </a:xfrm>
           <a:prstGeom prst="roundRect">
@@ -3798,9 +3798,9 @@
           <p:nvPr/>
         </p:nvCxnSpPr>
         <p:spPr>
-          <a:xfrm rot="16200000" flipH="1">
-            <a:off x="1399090" y="1517729"/>
-            <a:ext cx="558479" cy="648183"/>
+          <a:xfrm rot="5400000">
+            <a:off x="991807" y="1925013"/>
+            <a:ext cx="724863" cy="12700"/>
           </a:xfrm>
           <a:prstGeom prst="bentConnector3">
             <a:avLst/>
@@ -4231,58 +4231,15 @@
           </p:cNvPr>
           <p:cNvCxnSpPr>
             <a:cxnSpLocks/>
-            <a:stCxn id="7" idx="2"/>
+            <a:stCxn id="7" idx="3"/>
             <a:endCxn id="6" idx="1"/>
           </p:cNvCxnSpPr>
           <p:nvPr/>
         </p:nvCxnSpPr>
         <p:spPr>
-          <a:xfrm rot="16200000" flipH="1">
-            <a:off x="3477952" y="4834601"/>
-            <a:ext cx="449964" cy="1406323"/>
-          </a:xfrm>
-          <a:prstGeom prst="bentConnector2">
-            <a:avLst/>
-          </a:prstGeom>
-          <a:ln>
-            <a:tailEnd type="triangle"/>
-          </a:ln>
-        </p:spPr>
-        <p:style>
-          <a:lnRef idx="2">
-            <a:schemeClr val="accent1"/>
-          </a:lnRef>
-          <a:fillRef idx="0">
-            <a:schemeClr val="accent1"/>
-          </a:fillRef>
-          <a:effectRef idx="1">
-            <a:schemeClr val="accent1"/>
-          </a:effectRef>
-          <a:fontRef idx="minor">
-            <a:schemeClr val="tx1"/>
-          </a:fontRef>
-        </p:style>
-      </p:cxnSp>
-      <p:cxnSp>
-        <p:nvCxnSpPr>
-          <p:cNvPr id="14" name="Connector: Elbow 13">
-            <a:extLst>
-              <a:ext uri="{FF2B5EF4-FFF2-40B4-BE49-F238E27FC236}">
-                <a16:creationId xmlns:a16="http://schemas.microsoft.com/office/drawing/2014/main" id="{F1AE8A9D-F130-9A57-6040-6C4FA38FDA2B}"/>
-              </a:ext>
-            </a:extLst>
-          </p:cNvPr>
-          <p:cNvCxnSpPr>
-            <a:cxnSpLocks/>
-            <a:stCxn id="5" idx="2"/>
-            <a:endCxn id="7" idx="0"/>
-          </p:cNvCxnSpPr>
-          <p:nvPr/>
-        </p:nvCxnSpPr>
-        <p:spPr>
-          <a:xfrm rot="16200000" flipH="1">
-            <a:off x="2213176" y="3218245"/>
-            <a:ext cx="575842" cy="997352"/>
+          <a:xfrm>
+            <a:off x="5849076" y="5862579"/>
+            <a:ext cx="779360" cy="224255"/>
           </a:xfrm>
           <a:prstGeom prst="bentConnector3">
             <a:avLst>
@@ -4325,9 +4282,9 @@
           <p:nvPr/>
         </p:nvCxnSpPr>
         <p:spPr>
-          <a:xfrm>
-            <a:off x="6628436" y="5762745"/>
-            <a:ext cx="3061504" cy="186642"/>
+          <a:xfrm flipV="1">
+            <a:off x="8850776" y="5949387"/>
+            <a:ext cx="839164" cy="137447"/>
           </a:xfrm>
           <a:prstGeom prst="bentConnector3">
             <a:avLst>
@@ -4353,6 +4310,83 @@
           </a:fontRef>
         </p:style>
       </p:cxnSp>
+      <p:sp>
+        <p:nvSpPr>
+          <p:cNvPr id="18" name="Rectangle: Rounded Corners 17">
+            <a:extLst>
+              <a:ext uri="{FF2B5EF4-FFF2-40B4-BE49-F238E27FC236}">
+                <a16:creationId xmlns:a16="http://schemas.microsoft.com/office/drawing/2014/main" id="{E7794C9B-A479-EBDB-9346-4244A4F1D5A0}"/>
+              </a:ext>
+            </a:extLst>
+          </p:cNvPr>
+          <p:cNvSpPr/>
+          <p:nvPr/>
+        </p:nvSpPr>
+        <p:spPr>
+          <a:xfrm>
+            <a:off x="279720" y="4124925"/>
+            <a:ext cx="2222340" cy="1307939"/>
+          </a:xfrm>
+          <a:prstGeom prst="roundRect">
+            <a:avLst/>
+          </a:prstGeom>
+          <a:solidFill>
+            <a:schemeClr val="accent4"/>
+          </a:solidFill>
+        </p:spPr>
+        <p:style>
+          <a:lnRef idx="2">
+            <a:schemeClr val="accent1">
+              <a:shade val="15000"/>
+            </a:schemeClr>
+          </a:lnRef>
+          <a:fillRef idx="1">
+            <a:schemeClr val="accent1"/>
+          </a:fillRef>
+          <a:effectRef idx="0">
+            <a:schemeClr val="accent1"/>
+          </a:effectRef>
+          <a:fontRef idx="minor">
+            <a:schemeClr val="lt1"/>
+          </a:fontRef>
+        </p:style>
+        <p:txBody>
+          <a:bodyPr rtlCol="0" anchor="ctr"/>
+          <a:lstStyle/>
+          <a:p>
+            <a:pPr algn="ctr"/>
+            <a:r>
+              <a:rPr lang="en-US" dirty="0"/>
+              <a:t>L-Bracket</a:t>
+            </a:r>
+            <a:br>
+              <a:rPr lang="en-US" dirty="0"/>
+            </a:br>
+            <a:r>
+              <a:rPr lang="en-US" dirty="0">
+                <a:solidFill>
+                  <a:srgbClr val="FF0000"/>
+                </a:solidFill>
+              </a:rPr>
+              <a:t>5 Materials</a:t>
+            </a:r>
+          </a:p>
+          <a:p>
+            <a:pPr algn="ctr"/>
+            <a:r>
+              <a:rPr lang="en-US" dirty="0"/>
+              <a:t>Min Mass</a:t>
+            </a:r>
+          </a:p>
+          <a:p>
+            <a:pPr algn="ctr"/>
+            <a:r>
+              <a:rPr lang="en-US" dirty="0"/>
+              <a:t>Stress FF &lt; 0.5</a:t>
+            </a:r>
+          </a:p>
+        </p:txBody>
+      </p:sp>
     </p:spTree>
     <p:extLst>
       <p:ext uri="{BB962C8B-B14F-4D97-AF65-F5344CB8AC3E}">

</xml_diff>